<commit_message>
Verify data against multiple sources and apply 5 corrections
Co-Authored-By: Claude Opus 5 <noreply@anthropic.com>
Claude-Session: https://claude.ai/code/session_01M4ZixrUwc2nAuX1sbCXHA3
</commit_message>
<xml_diff>
--- a/ともき医療ワークス/02_作業中/講演スライド_経営層向け90分.pptx
+++ b/ともき医療ワークス/02_作業中/講演スライド_経営層向け90分.pptx
@@ -731,7 +731,7 @@
               <c:strCache>
                 <c:ptCount val="1"/>
                 <c:pt idx="0">
-                  <c:v>従来型の看護組織</c:v>
+                  <c:v>業界平均</c:v>
                 </c:pt>
               </c:strCache>
             </c:strRef>
@@ -774,10 +774,10 @@
                 <c:ptCount val="2"/>
                 <c:lvl>
                   <c:pt idx="0">
-                    <c:v>病気による欠勤率</c:v>
+                    <c:v>離職率</c:v>
                   </c:pt>
                   <c:pt idx="1">
-                    <c:v>離職率</c:v>
+                    <c:v>間接費</c:v>
                   </c:pt>
                 </c:lvl>
               </c:multiLvlStrCache>
@@ -790,10 +790,10 @@
                 <c:formatCode>General</c:formatCode>
                 <c:ptCount val="2"/>
                 <c:pt idx="0">
-                  <c:v>100</c:v>
+                  <c:v>15</c:v>
                 </c:pt>
                 <c:pt idx="1">
-                  <c:v>100</c:v>
+                  <c:v>25</c:v>
                 </c:pt>
               </c:numCache>
             </c:numRef>
@@ -851,10 +851,10 @@
                 <c:ptCount val="2"/>
                 <c:lvl>
                   <c:pt idx="0">
-                    <c:v>病気による欠勤率</c:v>
+                    <c:v>離職率</c:v>
                   </c:pt>
                   <c:pt idx="1">
-                    <c:v>離職率</c:v>
+                    <c:v>間接費</c:v>
                   </c:pt>
                 </c:lvl>
               </c:multiLvlStrCache>
@@ -867,10 +867,10 @@
                 <c:formatCode>General</c:formatCode>
                 <c:ptCount val="2"/>
                 <c:pt idx="0">
-                  <c:v>40</c:v>
+                  <c:v>10</c:v>
                 </c:pt>
                 <c:pt idx="1">
-                  <c:v>67</c:v>
+                  <c:v>8</c:v>
                 </c:pt>
               </c:numCache>
             </c:numRef>
@@ -951,7 +951,7 @@
         <c:axId val="2094734552"/>
         <c:scaling>
           <c:orientation val="minMax"/>
-          <c:max val="120"/>
+          <c:max val="30"/>
           <c:min val="0"/>
         </c:scaling>
         <c:delete val="0"/>
@@ -2318,7 +2318,7 @@
           <a:p>
             <a:r>
               <a:rPr lang="en-US" dirty="0"/>
-              <a:t>「〜と報告されています」と言う。断定しない。</a:t>
+              <a:t>「〜と報告されています」と言う。断定しない。60%とは言わないこと。33%は10%対15%で裏づけ済み。</a:t>
             </a:r>
             <a:endParaRPr lang="en-US" dirty="0"/>
           </a:p>
@@ -7395,7 +7395,7 @@
                 <a:ea typeface="Meiryo" pitchFamily="34" charset="-122"/>
                 <a:cs typeface="Meiryo" pitchFamily="34" charset="-120"/>
               </a:rPr>
-              <a:t>2.37</a:t>
+              <a:t>4.54</a:t>
             </a:r>
             <a:endParaRPr lang="en-US" sz="3400" dirty="0"/>
           </a:p>
@@ -7476,7 +7476,7 @@
                 <a:ea typeface="Meiryo" pitchFamily="34" charset="-122"/>
                 <a:cs typeface="Meiryo" pitchFamily="34" charset="-120"/>
               </a:rPr>
-              <a:t>看護師等の有効求人倍率</a:t>
+              <a:t>訪問看護ステーションの求人倍率</a:t>
             </a:r>
             <a:endParaRPr lang="en-US" sz="1100" dirty="0"/>
           </a:p>
@@ -7515,7 +7515,7 @@
                 <a:ea typeface="Meiryo" pitchFamily="34" charset="-122"/>
                 <a:cs typeface="Meiryo" pitchFamily="34" charset="-120"/>
               </a:rPr>
-              <a:t>14.6</a:t>
+              <a:t>2.37</a:t>
             </a:r>
             <a:endParaRPr lang="en-US" sz="3400" dirty="0"/>
           </a:p>
@@ -7554,7 +7554,7 @@
                 <a:ea typeface="Meiryo" pitchFamily="34" charset="-122"/>
                 <a:cs typeface="Meiryo" pitchFamily="34" charset="-120"/>
               </a:rPr>
-              <a:t>%</a:t>
+              <a:t>倍</a:t>
             </a:r>
             <a:endParaRPr lang="en-US" sz="1300" dirty="0"/>
           </a:p>
@@ -7596,7 +7596,7 @@
                 <a:ea typeface="Meiryo" pitchFamily="34" charset="-122"/>
                 <a:cs typeface="Meiryo" pitchFamily="34" charset="-120"/>
               </a:rPr>
-              <a:t>医療・福祉の離職率(令和5年)</a:t>
+              <a:t>看護師等の有効求人倍率(令和6年)</a:t>
             </a:r>
             <a:endParaRPr lang="en-US" sz="1100" dirty="0"/>
           </a:p>
@@ -9297,7 +9297,7 @@
                 <a:ea typeface="Meiryo" pitchFamily="34" charset="-122"/>
                 <a:cs typeface="Meiryo" pitchFamily="34" charset="-120"/>
               </a:rPr>
-              <a:t>60%低い</a:t>
+              <a:t>33%低い</a:t>
             </a:r>
             <a:endParaRPr lang="en-US" sz="2400" dirty="0"/>
           </a:p>
@@ -9336,7 +9336,7 @@
                 <a:ea typeface="Meiryo" pitchFamily="34" charset="-122"/>
                 <a:cs typeface="Meiryo" pitchFamily="34" charset="-120"/>
               </a:rPr>
-              <a:t>病気を理由にした欠勤率</a:t>
+              <a:t>離職率(10%対15%)</a:t>
             </a:r>
             <a:endParaRPr lang="en-US" sz="1200" dirty="0"/>
           </a:p>
@@ -9350,7 +9350,7 @@
         </p:nvSpPr>
         <p:spPr>
           <a:xfrm>
-            <a:off x="8183880" y="2834640"/>
+            <a:off x="8183880" y="2880360"/>
             <a:ext cx="3108960" cy="457200"/>
           </a:xfrm>
           <a:prstGeom prst="rect">
@@ -9367,7 +9367,7 @@
               <a:buNone/>
             </a:pPr>
             <a:r>
-              <a:rPr lang="en-US" sz="2000" b="1" dirty="0">
+              <a:rPr lang="en-US" sz="1800" b="1" dirty="0">
                 <a:solidFill>
                   <a:srgbClr val="1F2933"/>
                 </a:solidFill>
@@ -9375,9 +9375,9 @@
                 <a:ea typeface="Meiryo" pitchFamily="34" charset="-122"/>
                 <a:cs typeface="Meiryo" pitchFamily="34" charset="-120"/>
               </a:rPr>
-              <a:t>33%低い</a:t>
-            </a:r>
-            <a:endParaRPr lang="en-US" sz="2000" dirty="0"/>
+              <a:t>欠勤率は約半分</a:t>
+            </a:r>
+            <a:endParaRPr lang="en-US" sz="1800" dirty="0"/>
           </a:p>
         </p:txBody>
       </p:sp>
@@ -9540,7 +9540,7 @@
                 <a:ea typeface="Meiryo" pitchFamily="34" charset="-122"/>
                 <a:cs typeface="Meiryo" pitchFamily="34" charset="-120"/>
               </a:rPr>
-              <a:t>グラフは従来型を100とした指数です。出典:SELECK、We介護(二次情報)</a:t>
+              <a:t>グラフの単位は%。出典:KPMG(2015)等をもとにした報告。欠勤率は「業界平均の約半分」との記述です</a:t>
             </a:r>
             <a:endParaRPr lang="en-US" sz="1000" dirty="0"/>
           </a:p>
@@ -11927,7 +11927,7 @@
                 <a:ea typeface="Meiryo" pitchFamily="34" charset="-122"/>
                 <a:cs typeface="Meiryo" pitchFamily="34" charset="-120"/>
               </a:rPr>
-              <a:t>本資料の数値には二次情報が含まれます。引用の際は原典をご確認ください。</a:t>
+              <a:t>本資料の数値には二次情報が含まれます。未確認のものは、その旨を申し上げます。</a:t>
             </a:r>
             <a:endParaRPr lang="en-US" sz="1300" dirty="0"/>
           </a:p>

</xml_diff>